<commit_message>
Split onboarding into 3 linked decks + matching instruction docs
Three-deck onboarding system for new engineers:

1. Engineer Onboarding (9 slides) — project overview, tech stack,
   first week goals. Slide 3 links to the other two decks.

2. Dev Environment Setup (11 slides) — VS Code, Node.js, Claude Code,
   Xcode installation with step-by-step commands. Includes which
   editor to use for which file type.

3. GitHub Process (7 slides) — already existed, unchanged.

Matching instruction documents:
- docs/DEV-ENVIRONMENT-SETUP.md — full setup walkthrough with
  troubleshooting section
- docs/GITHUB-PROCESS.md — complete Git/GitHub workflow reference
  with commit standards, PR process, troubleshooting

Onboarding flow: start with main deck → dev environment → GitHub
process → pick a task from docs/TASKS.md

Co-Authored-By: Claude Opus 4.6 (1M context) <noreply@anthropic.com>
</commit_message>
<xml_diff>
--- a/pitch/Del-Norte-Engineer-Onboarding.pptx
+++ b/pitch/Del-Norte-Engineer-Onboarding.pptx
@@ -2325,7 +2325,7 @@
                 <a:ea typeface="Arial" pitchFamily="34" charset="-122"/>
                 <a:cs typeface="Arial" pitchFamily="34" charset="-120"/>
               </a:rPr>
-              <a:t>APNs (Apple Push Notifications) via hapns</a:t>
+              <a:t>APNs via hapns</a:t>
             </a:r>
             <a:endParaRPr lang="en-US" sz="1200" dirty="0"/>
           </a:p>
@@ -2481,7 +2481,7 @@
                 <a:ea typeface="Arial" pitchFamily="34" charset="-122"/>
                 <a:cs typeface="Arial" pitchFamily="34" charset="-120"/>
               </a:rPr>
-              <a:t>SwiftUI + PassKit framework</a:t>
+              <a:t>SwiftUI + PassKit</a:t>
             </a:r>
             <a:endParaRPr lang="en-US" sz="1200" dirty="0"/>
           </a:p>
@@ -2539,40 +2539,16 @@
           <a:ln/>
         </p:spPr>
       </p:sp>
-      <p:pic>
-        <p:nvPicPr>
-          <p:cNvPr id="3" name="Image 0" descr="preencoded.png">    </p:cNvPr>
-          <p:cNvPicPr>
-            <a:picLocks noChangeAspect="1"/>
-          </p:cNvPicPr>
-          <p:nvPr/>
-        </p:nvPicPr>
-        <p:blipFill>
-          <a:blip r:embed="rId1"/>
-          <a:stretch>
-            <a:fillRect/>
-          </a:stretch>
-        </p:blipFill>
-        <p:spPr>
-          <a:xfrm>
-            <a:off x="731520" y="320040"/>
-            <a:ext cx="457200" cy="457200"/>
-          </a:xfrm>
-          <a:prstGeom prst="rect">
-            <a:avLst/>
-          </a:prstGeom>
-        </p:spPr>
-      </p:pic>
-      <p:sp>
-        <p:nvSpPr>
-          <p:cNvPr id="4" name="Text 1"/>
-          <p:cNvSpPr/>
-          <p:nvPr/>
-        </p:nvSpPr>
-        <p:spPr>
-          <a:xfrm>
-            <a:off x="1371600" y="320040"/>
-            <a:ext cx="7315200" cy="457200"/>
+      <p:sp>
+        <p:nvSpPr>
+          <p:cNvPr id="3" name="Text 1"/>
+          <p:cNvSpPr/>
+          <p:nvPr/>
+        </p:nvSpPr>
+        <p:spPr>
+          <a:xfrm>
+            <a:off x="731520" y="365760"/>
+            <a:ext cx="8229600" cy="548640"/>
           </a:xfrm>
           <a:prstGeom prst="rect">
             <a:avLst/>
@@ -2596,7 +2572,7 @@
                 <a:ea typeface="Arial Black" pitchFamily="34" charset="-122"/>
                 <a:cs typeface="Arial Black" pitchFamily="34" charset="-120"/>
               </a:rPr>
-              <a:t>DAY 1 CHECKLIST</a:t>
+              <a:t>YOUR ONBOARDING JOURNEY</a:t>
             </a:r>
             <a:endParaRPr lang="en-US" sz="2400" dirty="0"/>
           </a:p>
@@ -2604,328 +2580,381 @@
       </p:sp>
       <p:sp>
         <p:nvSpPr>
-          <p:cNvPr id="5" name="Shape 2"/>
-          <p:cNvSpPr/>
-          <p:nvPr/>
-        </p:nvSpPr>
-        <p:spPr>
-          <a:xfrm>
-            <a:off x="548640" y="1005840"/>
-            <a:ext cx="8046720" cy="530352"/>
-          </a:xfrm>
-          <a:prstGeom prst="rect">
-            <a:avLst/>
-          </a:prstGeom>
-          <a:solidFill>
-            <a:srgbClr val="0A1A35"/>
-          </a:solidFill>
-          <a:ln/>
-        </p:spPr>
-      </p:sp>
-      <p:sp>
-        <p:nvSpPr>
-          <p:cNvPr id="6" name="Shape 3"/>
-          <p:cNvSpPr/>
-          <p:nvPr/>
-        </p:nvSpPr>
-        <p:spPr>
-          <a:xfrm>
-            <a:off x="548640" y="1005840"/>
-            <a:ext cx="64008" cy="530352"/>
-          </a:xfrm>
-          <a:prstGeom prst="rect">
-            <a:avLst/>
-          </a:prstGeom>
-          <a:solidFill>
-            <a:srgbClr val="C5A55A"/>
-          </a:solidFill>
-          <a:ln/>
-        </p:spPr>
-      </p:sp>
-      <p:sp>
-        <p:nvSpPr>
-          <p:cNvPr id="7" name="Text 4"/>
-          <p:cNvSpPr/>
-          <p:nvPr/>
-        </p:nvSpPr>
-        <p:spPr>
-          <a:xfrm>
-            <a:off x="822960" y="1005840"/>
-            <a:ext cx="1097280" cy="530352"/>
-          </a:xfrm>
-          <a:prstGeom prst="rect">
-            <a:avLst/>
-          </a:prstGeom>
-          <a:noFill/>
-          <a:ln/>
-        </p:spPr>
-        <p:txBody>
-          <a:bodyPr wrap="square" lIns="0" tIns="0" rIns="0" bIns="0" rtlCol="0" anchor="ctr"/>
-          <a:lstStyle/>
-          <a:p>
-            <a:pPr indent="0" marL="0">
-              <a:buNone/>
-            </a:pPr>
-            <a:r>
-              <a:rPr lang="en-US" sz="1100" b="1" dirty="0">
-                <a:solidFill>
-                  <a:srgbClr val="C5A55A"/>
+          <p:cNvPr id="4" name="Text 2"/>
+          <p:cNvSpPr/>
+          <p:nvPr/>
+        </p:nvSpPr>
+        <p:spPr>
+          <a:xfrm>
+            <a:off x="731520" y="914400"/>
+            <a:ext cx="7680960" cy="320040"/>
+          </a:xfrm>
+          <a:prstGeom prst="rect">
+            <a:avLst/>
+          </a:prstGeom>
+          <a:noFill/>
+          <a:ln/>
+        </p:spPr>
+        <p:txBody>
+          <a:bodyPr wrap="square" lIns="0" tIns="0" rIns="0" bIns="0" rtlCol="0" anchor="ctr"/>
+          <a:lstStyle/>
+          <a:p>
+            <a:pPr indent="0" marL="0">
+              <a:buNone/>
+            </a:pPr>
+            <a:r>
+              <a:rPr lang="en-US" sz="1300" i="1" dirty="0">
+                <a:solidFill>
+                  <a:srgbClr val="D4B96A"/>
                 </a:solidFill>
                 <a:latin typeface="Arial" pitchFamily="34" charset="0"/>
                 <a:ea typeface="Arial" pitchFamily="34" charset="-122"/>
                 <a:cs typeface="Arial" pitchFamily="34" charset="-120"/>
               </a:rPr>
-              <a:t>30 min</a:t>
-            </a:r>
-            <a:endParaRPr lang="en-US" sz="1100" dirty="0"/>
-          </a:p>
-        </p:txBody>
-      </p:sp>
-      <p:sp>
-        <p:nvSpPr>
-          <p:cNvPr id="8" name="Text 5"/>
-          <p:cNvSpPr/>
-          <p:nvPr/>
-        </p:nvSpPr>
-        <p:spPr>
-          <a:xfrm>
-            <a:off x="2011680" y="1005840"/>
-            <a:ext cx="4114800" cy="530352"/>
-          </a:xfrm>
-          <a:prstGeom prst="rect">
-            <a:avLst/>
-          </a:prstGeom>
-          <a:noFill/>
-          <a:ln/>
-        </p:spPr>
-        <p:txBody>
-          <a:bodyPr wrap="square" lIns="0" tIns="0" rIns="0" bIns="0" rtlCol="0" anchor="ctr"/>
-          <a:lstStyle/>
-          <a:p>
-            <a:pPr indent="0" marL="0">
-              <a:buNone/>
-            </a:pPr>
-            <a:r>
-              <a:rPr lang="en-US" sz="1200" dirty="0">
-                <a:solidFill>
-                  <a:srgbClr val="FFFFFF"/>
+              <a:t>Three decks walk you through everything:</a:t>
+            </a:r>
+            <a:endParaRPr lang="en-US" sz="1300" dirty="0"/>
+          </a:p>
+        </p:txBody>
+      </p:sp>
+      <p:sp>
+        <p:nvSpPr>
+          <p:cNvPr id="5" name="Shape 3"/>
+          <p:cNvSpPr/>
+          <p:nvPr/>
+        </p:nvSpPr>
+        <p:spPr>
+          <a:xfrm>
+            <a:off x="548640" y="1371600"/>
+            <a:ext cx="8046720" cy="1005840"/>
+          </a:xfrm>
+          <a:prstGeom prst="rect">
+            <a:avLst/>
+          </a:prstGeom>
+          <a:solidFill>
+            <a:srgbClr val="0A1A35"/>
+          </a:solidFill>
+          <a:ln/>
+          <a:effectLst>
+            <a:outerShdw sx="100000" sy="100000" kx="0" ky="0" algn="bl" rotWithShape="0" blurRad="101600" dist="38100" dir="8100000">
+              <a:srgbClr val="000000">
+                <a:alpha val="20000"/>
+              </a:srgbClr>
+            </a:outerShdw>
+          </a:effectLst>
+        </p:spPr>
+      </p:sp>
+      <p:sp>
+        <p:nvSpPr>
+          <p:cNvPr id="6" name="Shape 4"/>
+          <p:cNvSpPr/>
+          <p:nvPr/>
+        </p:nvSpPr>
+        <p:spPr>
+          <a:xfrm>
+            <a:off x="548640" y="1371600"/>
+            <a:ext cx="91440" cy="1005840"/>
+          </a:xfrm>
+          <a:prstGeom prst="rect">
+            <a:avLst/>
+          </a:prstGeom>
+          <a:solidFill>
+            <a:srgbClr val="C5A55A"/>
+          </a:solidFill>
+          <a:ln/>
+        </p:spPr>
+      </p:sp>
+      <p:sp>
+        <p:nvSpPr>
+          <p:cNvPr id="7" name="Text 5"/>
+          <p:cNvSpPr/>
+          <p:nvPr/>
+        </p:nvSpPr>
+        <p:spPr>
+          <a:xfrm>
+            <a:off x="822960" y="1463040"/>
+            <a:ext cx="7498080" cy="320040"/>
+          </a:xfrm>
+          <a:prstGeom prst="rect">
+            <a:avLst/>
+          </a:prstGeom>
+          <a:noFill/>
+          <a:ln/>
+        </p:spPr>
+        <p:txBody>
+          <a:bodyPr wrap="square" lIns="0" tIns="0" rIns="0" bIns="0" rtlCol="0" anchor="ctr"/>
+          <a:lstStyle/>
+          <a:p>
+            <a:pPr indent="0" marL="0">
+              <a:buNone/>
+            </a:pPr>
+            <a:r>
+              <a:rPr lang="en-US" sz="1400" b="1" dirty="0">
+                <a:solidFill>
+                  <a:srgbClr val="C5A55A"/>
                 </a:solidFill>
                 <a:latin typeface="Arial" pitchFamily="34" charset="0"/>
                 <a:ea typeface="Arial" pitchFamily="34" charset="-122"/>
                 <a:cs typeface="Arial" pitchFamily="34" charset="-120"/>
               </a:rPr>
-              <a:t>Accept GitHub collaborator invite</a:t>
-            </a:r>
-            <a:endParaRPr lang="en-US" sz="1200" dirty="0"/>
-          </a:p>
-        </p:txBody>
-      </p:sp>
-      <p:sp>
-        <p:nvSpPr>
-          <p:cNvPr id="9" name="Text 6"/>
-          <p:cNvSpPr/>
-          <p:nvPr/>
-        </p:nvSpPr>
-        <p:spPr>
-          <a:xfrm>
-            <a:off x="6217920" y="1005840"/>
-            <a:ext cx="2194560" cy="530352"/>
-          </a:xfrm>
-          <a:prstGeom prst="rect">
-            <a:avLst/>
-          </a:prstGeom>
-          <a:noFill/>
-          <a:ln/>
-        </p:spPr>
-        <p:txBody>
-          <a:bodyPr wrap="square" lIns="0" tIns="0" rIns="0" bIns="0" rtlCol="0" anchor="ctr"/>
-          <a:lstStyle/>
-          <a:p>
-            <a:pPr indent="0" marL="0">
-              <a:buNone/>
-            </a:pPr>
-            <a:r>
-              <a:rPr lang="en-US" sz="1000" i="1" dirty="0">
-                <a:solidFill>
-                  <a:srgbClr val="A0A0A0"/>
+              <a:t>1. Engineer Onboarding (this deck)</a:t>
+            </a:r>
+            <a:endParaRPr lang="en-US" sz="1400" dirty="0"/>
+          </a:p>
+        </p:txBody>
+      </p:sp>
+      <p:sp>
+        <p:nvSpPr>
+          <p:cNvPr id="8" name="Text 6"/>
+          <p:cNvSpPr/>
+          <p:nvPr/>
+        </p:nvSpPr>
+        <p:spPr>
+          <a:xfrm>
+            <a:off x="822960" y="1783080"/>
+            <a:ext cx="7498080" cy="274320"/>
+          </a:xfrm>
+          <a:prstGeom prst="rect">
+            <a:avLst/>
+          </a:prstGeom>
+          <a:noFill/>
+          <a:ln/>
+        </p:spPr>
+        <p:txBody>
+          <a:bodyPr wrap="square" lIns="0" tIns="0" rIns="0" bIns="0" rtlCol="0" anchor="ctr"/>
+          <a:lstStyle/>
+          <a:p>
+            <a:pPr indent="0" marL="0">
+              <a:buNone/>
+            </a:pPr>
+            <a:r>
+              <a:rPr lang="en-US" sz="1100" dirty="0">
+                <a:solidFill>
+                  <a:srgbClr val="FFFFFF"/>
                 </a:solidFill>
                 <a:latin typeface="Arial" pitchFamily="34" charset="0"/>
                 <a:ea typeface="Arial" pitchFamily="34" charset="-122"/>
                 <a:cs typeface="Arial" pitchFamily="34" charset="-120"/>
               </a:rPr>
-              <a:t>Check email</a:t>
-            </a:r>
-            <a:endParaRPr lang="en-US" sz="1000" dirty="0"/>
-          </a:p>
-        </p:txBody>
-      </p:sp>
-      <p:sp>
-        <p:nvSpPr>
-          <p:cNvPr id="10" name="Shape 7"/>
-          <p:cNvSpPr/>
-          <p:nvPr/>
-        </p:nvSpPr>
-        <p:spPr>
-          <a:xfrm>
-            <a:off x="548640" y="1627632"/>
-            <a:ext cx="8046720" cy="530352"/>
-          </a:xfrm>
-          <a:prstGeom prst="rect">
-            <a:avLst/>
-          </a:prstGeom>
-          <a:solidFill>
-            <a:srgbClr val="0A1A35"/>
-          </a:solidFill>
-          <a:ln/>
-        </p:spPr>
-      </p:sp>
-      <p:sp>
-        <p:nvSpPr>
-          <p:cNvPr id="11" name="Shape 8"/>
-          <p:cNvSpPr/>
-          <p:nvPr/>
-        </p:nvSpPr>
-        <p:spPr>
-          <a:xfrm>
-            <a:off x="548640" y="1627632"/>
-            <a:ext cx="64008" cy="530352"/>
-          </a:xfrm>
-          <a:prstGeom prst="rect">
-            <a:avLst/>
-          </a:prstGeom>
-          <a:solidFill>
-            <a:srgbClr val="C5A55A"/>
-          </a:solidFill>
-          <a:ln/>
-        </p:spPr>
-      </p:sp>
-      <p:sp>
-        <p:nvSpPr>
-          <p:cNvPr id="12" name="Text 9"/>
-          <p:cNvSpPr/>
-          <p:nvPr/>
-        </p:nvSpPr>
-        <p:spPr>
-          <a:xfrm>
-            <a:off x="822960" y="1627632"/>
-            <a:ext cx="1097280" cy="530352"/>
-          </a:xfrm>
-          <a:prstGeom prst="rect">
-            <a:avLst/>
-          </a:prstGeom>
-          <a:noFill/>
-          <a:ln/>
-        </p:spPr>
-        <p:txBody>
-          <a:bodyPr wrap="square" lIns="0" tIns="0" rIns="0" bIns="0" rtlCol="0" anchor="ctr"/>
-          <a:lstStyle/>
-          <a:p>
-            <a:pPr indent="0" marL="0">
-              <a:buNone/>
-            </a:pPr>
-            <a:r>
-              <a:rPr lang="en-US" sz="1100" b="1" dirty="0">
-                <a:solidFill>
-                  <a:srgbClr val="C5A55A"/>
+              <a:t>Project overview, tech stack, first-week goals, where to find things.</a:t>
+            </a:r>
+            <a:endParaRPr lang="en-US" sz="1100" dirty="0"/>
+          </a:p>
+        </p:txBody>
+      </p:sp>
+      <p:sp>
+        <p:nvSpPr>
+          <p:cNvPr id="9" name="Text 7"/>
+          <p:cNvSpPr/>
+          <p:nvPr/>
+        </p:nvSpPr>
+        <p:spPr>
+          <a:xfrm>
+            <a:off x="822960" y="2057400"/>
+            <a:ext cx="7498080" cy="228600"/>
+          </a:xfrm>
+          <a:prstGeom prst="rect">
+            <a:avLst/>
+          </a:prstGeom>
+          <a:noFill/>
+          <a:ln/>
+        </p:spPr>
+        <p:txBody>
+          <a:bodyPr wrap="square" lIns="0" tIns="0" rIns="0" bIns="0" rtlCol="0" anchor="ctr"/>
+          <a:lstStyle/>
+          <a:p>
+            <a:pPr indent="0" marL="0">
+              <a:buNone/>
+            </a:pPr>
+            <a:r>
+              <a:rPr lang="en-US" sz="1000" i="1" dirty="0">
+                <a:solidFill>
+                  <a:srgbClr val="A0A0A0"/>
                 </a:solidFill>
                 <a:latin typeface="Arial" pitchFamily="34" charset="0"/>
                 <a:ea typeface="Arial" pitchFamily="34" charset="-122"/>
                 <a:cs typeface="Arial" pitchFamily="34" charset="-120"/>
               </a:rPr>
-              <a:t>20 min</a:t>
-            </a:r>
-            <a:endParaRPr lang="en-US" sz="1100" dirty="0"/>
-          </a:p>
-        </p:txBody>
-      </p:sp>
-      <p:sp>
-        <p:nvSpPr>
-          <p:cNvPr id="13" name="Text 10"/>
-          <p:cNvSpPr/>
-          <p:nvPr/>
-        </p:nvSpPr>
-        <p:spPr>
-          <a:xfrm>
-            <a:off x="2011680" y="1627632"/>
-            <a:ext cx="4114800" cy="530352"/>
-          </a:xfrm>
-          <a:prstGeom prst="rect">
-            <a:avLst/>
-          </a:prstGeom>
-          <a:noFill/>
-          <a:ln/>
-        </p:spPr>
-        <p:txBody>
-          <a:bodyPr wrap="square" lIns="0" tIns="0" rIns="0" bIns="0" rtlCol="0" anchor="ctr"/>
-          <a:lstStyle/>
-          <a:p>
-            <a:pPr indent="0" marL="0">
-              <a:buNone/>
-            </a:pPr>
-            <a:r>
-              <a:rPr lang="en-US" sz="1200" dirty="0">
-                <a:solidFill>
-                  <a:srgbClr val="FFFFFF"/>
+              <a:t>Start here (you're already here).</a:t>
+            </a:r>
+            <a:endParaRPr lang="en-US" sz="1000" dirty="0"/>
+          </a:p>
+        </p:txBody>
+      </p:sp>
+      <p:sp>
+        <p:nvSpPr>
+          <p:cNvPr id="10" name="Shape 8"/>
+          <p:cNvSpPr/>
+          <p:nvPr/>
+        </p:nvSpPr>
+        <p:spPr>
+          <a:xfrm>
+            <a:off x="548640" y="2514600"/>
+            <a:ext cx="8046720" cy="1005840"/>
+          </a:xfrm>
+          <a:prstGeom prst="rect">
+            <a:avLst/>
+          </a:prstGeom>
+          <a:solidFill>
+            <a:srgbClr val="0A1A35"/>
+          </a:solidFill>
+          <a:ln/>
+          <a:effectLst>
+            <a:outerShdw sx="100000" sy="100000" kx="0" ky="0" algn="bl" rotWithShape="0" blurRad="101600" dist="38100" dir="8100000">
+              <a:srgbClr val="000000">
+                <a:alpha val="20000"/>
+              </a:srgbClr>
+            </a:outerShdw>
+          </a:effectLst>
+        </p:spPr>
+      </p:sp>
+      <p:sp>
+        <p:nvSpPr>
+          <p:cNvPr id="11" name="Shape 9"/>
+          <p:cNvSpPr/>
+          <p:nvPr/>
+        </p:nvSpPr>
+        <p:spPr>
+          <a:xfrm>
+            <a:off x="548640" y="2514600"/>
+            <a:ext cx="91440" cy="1005840"/>
+          </a:xfrm>
+          <a:prstGeom prst="rect">
+            <a:avLst/>
+          </a:prstGeom>
+          <a:solidFill>
+            <a:srgbClr val="C5A55A"/>
+          </a:solidFill>
+          <a:ln/>
+        </p:spPr>
+      </p:sp>
+      <p:sp>
+        <p:nvSpPr>
+          <p:cNvPr id="12" name="Text 10"/>
+          <p:cNvSpPr/>
+          <p:nvPr/>
+        </p:nvSpPr>
+        <p:spPr>
+          <a:xfrm>
+            <a:off x="822960" y="2606040"/>
+            <a:ext cx="7498080" cy="320040"/>
+          </a:xfrm>
+          <a:prstGeom prst="rect">
+            <a:avLst/>
+          </a:prstGeom>
+          <a:noFill/>
+          <a:ln/>
+        </p:spPr>
+        <p:txBody>
+          <a:bodyPr wrap="square" lIns="0" tIns="0" rIns="0" bIns="0" rtlCol="0" anchor="ctr"/>
+          <a:lstStyle/>
+          <a:p>
+            <a:pPr indent="0" marL="0">
+              <a:buNone/>
+            </a:pPr>
+            <a:r>
+              <a:rPr lang="en-US" sz="1400" b="1" dirty="0">
+                <a:solidFill>
+                  <a:srgbClr val="C5A55A"/>
                 </a:solidFill>
                 <a:latin typeface="Arial" pitchFamily="34" charset="0"/>
                 <a:ea typeface="Arial" pitchFamily="34" charset="-122"/>
                 <a:cs typeface="Arial" pitchFamily="34" charset="-120"/>
               </a:rPr>
-              <a:t>Read README.md and docs/CONTRIBUTING.md</a:t>
-            </a:r>
-            <a:endParaRPr lang="en-US" sz="1200" dirty="0"/>
-          </a:p>
-        </p:txBody>
-      </p:sp>
-      <p:sp>
-        <p:nvSpPr>
-          <p:cNvPr id="14" name="Text 11"/>
-          <p:cNvSpPr/>
-          <p:nvPr/>
-        </p:nvSpPr>
-        <p:spPr>
-          <a:xfrm>
-            <a:off x="6217920" y="1627632"/>
-            <a:ext cx="2194560" cy="530352"/>
-          </a:xfrm>
-          <a:prstGeom prst="rect">
-            <a:avLst/>
-          </a:prstGeom>
-          <a:noFill/>
-          <a:ln/>
-        </p:spPr>
-        <p:txBody>
-          <a:bodyPr wrap="square" lIns="0" tIns="0" rIns="0" bIns="0" rtlCol="0" anchor="ctr"/>
-          <a:lstStyle/>
-          <a:p>
-            <a:pPr indent="0" marL="0">
-              <a:buNone/>
-            </a:pPr>
-            <a:r>
-              <a:rPr lang="en-US" sz="1000" i="1" dirty="0">
-                <a:solidFill>
-                  <a:srgbClr val="A0A0A0"/>
+              <a:t>2. Dev Environment Setup</a:t>
+            </a:r>
+            <a:endParaRPr lang="en-US" sz="1400" dirty="0"/>
+          </a:p>
+        </p:txBody>
+      </p:sp>
+      <p:sp>
+        <p:nvSpPr>
+          <p:cNvPr id="13" name="Text 11"/>
+          <p:cNvSpPr/>
+          <p:nvPr/>
+        </p:nvSpPr>
+        <p:spPr>
+          <a:xfrm>
+            <a:off x="822960" y="2926080"/>
+            <a:ext cx="7498080" cy="274320"/>
+          </a:xfrm>
+          <a:prstGeom prst="rect">
+            <a:avLst/>
+          </a:prstGeom>
+          <a:noFill/>
+          <a:ln/>
+        </p:spPr>
+        <p:txBody>
+          <a:bodyPr wrap="square" lIns="0" tIns="0" rIns="0" bIns="0" rtlCol="0" anchor="ctr"/>
+          <a:lstStyle/>
+          <a:p>
+            <a:pPr indent="0" marL="0">
+              <a:buNone/>
+            </a:pPr>
+            <a:r>
+              <a:rPr lang="en-US" sz="1100" dirty="0">
+                <a:solidFill>
+                  <a:srgbClr val="FFFFFF"/>
                 </a:solidFill>
                 <a:latin typeface="Arial" pitchFamily="34" charset="0"/>
                 <a:ea typeface="Arial" pitchFamily="34" charset="-122"/>
                 <a:cs typeface="Arial" pitchFamily="34" charset="-120"/>
               </a:rPr>
-              <a:t>Get the full picture</a:t>
-            </a:r>
-            <a:endParaRPr lang="en-US" sz="1000" dirty="0"/>
-          </a:p>
-        </p:txBody>
-      </p:sp>
-      <p:sp>
-        <p:nvSpPr>
-          <p:cNvPr id="15" name="Shape 12"/>
-          <p:cNvSpPr/>
-          <p:nvPr/>
-        </p:nvSpPr>
-        <p:spPr>
-          <a:xfrm>
-            <a:off x="548640" y="2249424"/>
-            <a:ext cx="8046720" cy="530352"/>
+              <a:t>Install VS Code, Node.js, Claude Code, Xcode. Run the project locally.</a:t>
+            </a:r>
+            <a:endParaRPr lang="en-US" sz="1100" dirty="0"/>
+          </a:p>
+        </p:txBody>
+      </p:sp>
+      <p:sp>
+        <p:nvSpPr>
+          <p:cNvPr id="14" name="Text 12"/>
+          <p:cNvSpPr/>
+          <p:nvPr/>
+        </p:nvSpPr>
+        <p:spPr>
+          <a:xfrm>
+            <a:off x="822960" y="3200400"/>
+            <a:ext cx="7498080" cy="228600"/>
+          </a:xfrm>
+          <a:prstGeom prst="rect">
+            <a:avLst/>
+          </a:prstGeom>
+          <a:noFill/>
+          <a:ln/>
+        </p:spPr>
+        <p:txBody>
+          <a:bodyPr wrap="square" lIns="0" tIns="0" rIns="0" bIns="0" rtlCol="0" anchor="ctr"/>
+          <a:lstStyle/>
+          <a:p>
+            <a:pPr indent="0" marL="0">
+              <a:buNone/>
+            </a:pPr>
+            <a:r>
+              <a:rPr lang="en-US" sz="900" i="1" dirty="0">
+                <a:solidFill>
+                  <a:srgbClr val="A0A0A0"/>
+                </a:solidFill>
+                <a:latin typeface="monospace" pitchFamily="34" charset="0"/>
+                <a:ea typeface="monospace" pitchFamily="34" charset="-122"/>
+                <a:cs typeface="monospace" pitchFamily="34" charset="-120"/>
+              </a:rPr>
+              <a:t>File: pitch/Del-Norte-Dev-Environment-Setup.pptx · docs/DEV-ENVIRONMENT-SETUP.md</a:t>
+            </a:r>
+            <a:endParaRPr lang="en-US" sz="900" dirty="0"/>
+          </a:p>
+        </p:txBody>
+      </p:sp>
+      <p:sp>
+        <p:nvSpPr>
+          <p:cNvPr id="15" name="Shape 13"/>
+          <p:cNvSpPr/>
+          <p:nvPr/>
+        </p:nvSpPr>
+        <p:spPr>
+          <a:xfrm>
+            <a:off x="548640" y="3657600"/>
+            <a:ext cx="8046720" cy="1005840"/>
           </a:xfrm>
           <a:prstGeom prst="rect">
             <a:avLst/>
@@ -2934,18 +2963,25 @@
             <a:srgbClr val="0A1A35"/>
           </a:solidFill>
           <a:ln/>
-        </p:spPr>
-      </p:sp>
-      <p:sp>
-        <p:nvSpPr>
-          <p:cNvPr id="16" name="Shape 13"/>
-          <p:cNvSpPr/>
-          <p:nvPr/>
-        </p:nvSpPr>
-        <p:spPr>
-          <a:xfrm>
-            <a:off x="548640" y="2249424"/>
-            <a:ext cx="64008" cy="530352"/>
+          <a:effectLst>
+            <a:outerShdw sx="100000" sy="100000" kx="0" ky="0" algn="bl" rotWithShape="0" blurRad="101600" dist="38100" dir="8100000">
+              <a:srgbClr val="000000">
+                <a:alpha val="20000"/>
+              </a:srgbClr>
+            </a:outerShdw>
+          </a:effectLst>
+        </p:spPr>
+      </p:sp>
+      <p:sp>
+        <p:nvSpPr>
+          <p:cNvPr id="16" name="Shape 14"/>
+          <p:cNvSpPr/>
+          <p:nvPr/>
+        </p:nvSpPr>
+        <p:spPr>
+          <a:xfrm>
+            <a:off x="548640" y="3657600"/>
+            <a:ext cx="91440" cy="1005840"/>
           </a:xfrm>
           <a:prstGeom prst="rect">
             <a:avLst/>
@@ -2958,30 +2994,30 @@
       </p:sp>
       <p:sp>
         <p:nvSpPr>
-          <p:cNvPr id="17" name="Text 14"/>
-          <p:cNvSpPr/>
-          <p:nvPr/>
-        </p:nvSpPr>
-        <p:spPr>
-          <a:xfrm>
-            <a:off x="822960" y="2249424"/>
-            <a:ext cx="1097280" cy="530352"/>
-          </a:xfrm>
-          <a:prstGeom prst="rect">
-            <a:avLst/>
-          </a:prstGeom>
-          <a:noFill/>
-          <a:ln/>
-        </p:spPr>
-        <p:txBody>
-          <a:bodyPr wrap="square" lIns="0" tIns="0" rIns="0" bIns="0" rtlCol="0" anchor="ctr"/>
-          <a:lstStyle/>
-          <a:p>
-            <a:pPr indent="0" marL="0">
-              <a:buNone/>
-            </a:pPr>
-            <a:r>
-              <a:rPr lang="en-US" sz="1100" b="1" dirty="0">
+          <p:cNvPr id="17" name="Text 15"/>
+          <p:cNvSpPr/>
+          <p:nvPr/>
+        </p:nvSpPr>
+        <p:spPr>
+          <a:xfrm>
+            <a:off x="822960" y="3749040"/>
+            <a:ext cx="7498080" cy="320040"/>
+          </a:xfrm>
+          <a:prstGeom prst="rect">
+            <a:avLst/>
+          </a:prstGeom>
+          <a:noFill/>
+          <a:ln/>
+        </p:spPr>
+        <p:txBody>
+          <a:bodyPr wrap="square" lIns="0" tIns="0" rIns="0" bIns="0" rtlCol="0" anchor="ctr"/>
+          <a:lstStyle/>
+          <a:p>
+            <a:pPr indent="0" marL="0">
+              <a:buNone/>
+            </a:pPr>
+            <a:r>
+              <a:rPr lang="en-US" sz="1400" b="1" dirty="0">
                 <a:solidFill>
                   <a:srgbClr val="C5A55A"/>
                 </a:solidFill>
@@ -2989,38 +3025,38 @@
                 <a:ea typeface="Arial" pitchFamily="34" charset="-122"/>
                 <a:cs typeface="Arial" pitchFamily="34" charset="-120"/>
               </a:rPr>
-              <a:t>15 min</a:t>
-            </a:r>
-            <a:endParaRPr lang="en-US" sz="1100" dirty="0"/>
-          </a:p>
-        </p:txBody>
-      </p:sp>
-      <p:sp>
-        <p:nvSpPr>
-          <p:cNvPr id="18" name="Text 15"/>
-          <p:cNvSpPr/>
-          <p:nvPr/>
-        </p:nvSpPr>
-        <p:spPr>
-          <a:xfrm>
-            <a:off x="2011680" y="2249424"/>
-            <a:ext cx="4114800" cy="530352"/>
-          </a:xfrm>
-          <a:prstGeom prst="rect">
-            <a:avLst/>
-          </a:prstGeom>
-          <a:noFill/>
-          <a:ln/>
-        </p:spPr>
-        <p:txBody>
-          <a:bodyPr wrap="square" lIns="0" tIns="0" rIns="0" bIns="0" rtlCol="0" anchor="ctr"/>
-          <a:lstStyle/>
-          <a:p>
-            <a:pPr indent="0" marL="0">
-              <a:buNone/>
-            </a:pPr>
-            <a:r>
-              <a:rPr lang="en-US" sz="1200" dirty="0">
+              <a:t>3. GitHub Process</a:t>
+            </a:r>
+            <a:endParaRPr lang="en-US" sz="1400" dirty="0"/>
+          </a:p>
+        </p:txBody>
+      </p:sp>
+      <p:sp>
+        <p:nvSpPr>
+          <p:cNvPr id="18" name="Text 16"/>
+          <p:cNvSpPr/>
+          <p:nvPr/>
+        </p:nvSpPr>
+        <p:spPr>
+          <a:xfrm>
+            <a:off x="822960" y="4069080"/>
+            <a:ext cx="7498080" cy="274320"/>
+          </a:xfrm>
+          <a:prstGeom prst="rect">
+            <a:avLst/>
+          </a:prstGeom>
+          <a:noFill/>
+          <a:ln/>
+        </p:spPr>
+        <p:txBody>
+          <a:bodyPr wrap="square" lIns="0" tIns="0" rIns="0" bIns="0" rtlCol="0" anchor="ctr"/>
+          <a:lstStyle/>
+          <a:p>
+            <a:pPr indent="0" marL="0">
+              <a:buNone/>
+            </a:pPr>
+            <a:r>
+              <a:rPr lang="en-US" sz="1100" dirty="0">
                 <a:solidFill>
                   <a:srgbClr val="FFFFFF"/>
                 </a:solidFill>
@@ -3028,519 +3064,48 @@
                 <a:ea typeface="Arial" pitchFamily="34" charset="-122"/>
                 <a:cs typeface="Arial" pitchFamily="34" charset="-120"/>
               </a:rPr>
-              <a:t>Install Node.js 18+ and clone the repo</a:t>
-            </a:r>
-            <a:endParaRPr lang="en-US" sz="1200" dirty="0"/>
-          </a:p>
-        </p:txBody>
-      </p:sp>
-      <p:sp>
-        <p:nvSpPr>
-          <p:cNvPr id="19" name="Text 16"/>
-          <p:cNvSpPr/>
-          <p:nvPr/>
-        </p:nvSpPr>
-        <p:spPr>
-          <a:xfrm>
-            <a:off x="6217920" y="2249424"/>
-            <a:ext cx="2194560" cy="530352"/>
-          </a:xfrm>
-          <a:prstGeom prst="rect">
-            <a:avLst/>
-          </a:prstGeom>
-          <a:noFill/>
-          <a:ln/>
-        </p:spPr>
-        <p:txBody>
-          <a:bodyPr wrap="square" lIns="0" tIns="0" rIns="0" bIns="0" rtlCol="0" anchor="ctr"/>
-          <a:lstStyle/>
-          <a:p>
-            <a:pPr indent="0" marL="0">
-              <a:buNone/>
-            </a:pPr>
-            <a:r>
-              <a:rPr lang="en-US" sz="1000" i="1" dirty="0">
+              <a:t>Branching, commits, pull requests, code review workflow.</a:t>
+            </a:r>
+            <a:endParaRPr lang="en-US" sz="1100" dirty="0"/>
+          </a:p>
+        </p:txBody>
+      </p:sp>
+      <p:sp>
+        <p:nvSpPr>
+          <p:cNvPr id="19" name="Text 17"/>
+          <p:cNvSpPr/>
+          <p:nvPr/>
+        </p:nvSpPr>
+        <p:spPr>
+          <a:xfrm>
+            <a:off x="822960" y="4343400"/>
+            <a:ext cx="7498080" cy="228600"/>
+          </a:xfrm>
+          <a:prstGeom prst="rect">
+            <a:avLst/>
+          </a:prstGeom>
+          <a:noFill/>
+          <a:ln/>
+        </p:spPr>
+        <p:txBody>
+          <a:bodyPr wrap="square" lIns="0" tIns="0" rIns="0" bIns="0" rtlCol="0" anchor="ctr"/>
+          <a:lstStyle/>
+          <a:p>
+            <a:pPr indent="0" marL="0">
+              <a:buNone/>
+            </a:pPr>
+            <a:r>
+              <a:rPr lang="en-US" sz="900" i="1" dirty="0">
                 <a:solidFill>
                   <a:srgbClr val="A0A0A0"/>
                 </a:solidFill>
-                <a:latin typeface="Arial" pitchFamily="34" charset="0"/>
-                <a:ea typeface="Arial" pitchFamily="34" charset="-122"/>
-                <a:cs typeface="Arial" pitchFamily="34" charset="-120"/>
-              </a:rPr>
-              <a:t>brew install node</a:t>
-            </a:r>
-            <a:endParaRPr lang="en-US" sz="1000" dirty="0"/>
-          </a:p>
-        </p:txBody>
-      </p:sp>
-      <p:sp>
-        <p:nvSpPr>
-          <p:cNvPr id="20" name="Shape 17"/>
-          <p:cNvSpPr/>
-          <p:nvPr/>
-        </p:nvSpPr>
-        <p:spPr>
-          <a:xfrm>
-            <a:off x="548640" y="2871216"/>
-            <a:ext cx="8046720" cy="530352"/>
-          </a:xfrm>
-          <a:prstGeom prst="rect">
-            <a:avLst/>
-          </a:prstGeom>
-          <a:solidFill>
-            <a:srgbClr val="0A1A35"/>
-          </a:solidFill>
-          <a:ln/>
-        </p:spPr>
-      </p:sp>
-      <p:sp>
-        <p:nvSpPr>
-          <p:cNvPr id="21" name="Shape 18"/>
-          <p:cNvSpPr/>
-          <p:nvPr/>
-        </p:nvSpPr>
-        <p:spPr>
-          <a:xfrm>
-            <a:off x="548640" y="2871216"/>
-            <a:ext cx="64008" cy="530352"/>
-          </a:xfrm>
-          <a:prstGeom prst="rect">
-            <a:avLst/>
-          </a:prstGeom>
-          <a:solidFill>
-            <a:srgbClr val="C5A55A"/>
-          </a:solidFill>
-          <a:ln/>
-        </p:spPr>
-      </p:sp>
-      <p:sp>
-        <p:nvSpPr>
-          <p:cNvPr id="22" name="Text 19"/>
-          <p:cNvSpPr/>
-          <p:nvPr/>
-        </p:nvSpPr>
-        <p:spPr>
-          <a:xfrm>
-            <a:off x="822960" y="2871216"/>
-            <a:ext cx="1097280" cy="530352"/>
-          </a:xfrm>
-          <a:prstGeom prst="rect">
-            <a:avLst/>
-          </a:prstGeom>
-          <a:noFill/>
-          <a:ln/>
-        </p:spPr>
-        <p:txBody>
-          <a:bodyPr wrap="square" lIns="0" tIns="0" rIns="0" bIns="0" rtlCol="0" anchor="ctr"/>
-          <a:lstStyle/>
-          <a:p>
-            <a:pPr indent="0" marL="0">
-              <a:buNone/>
-            </a:pPr>
-            <a:r>
-              <a:rPr lang="en-US" sz="1100" b="1" dirty="0">
-                <a:solidFill>
-                  <a:srgbClr val="C5A55A"/>
-                </a:solidFill>
-                <a:latin typeface="Arial" pitchFamily="34" charset="0"/>
-                <a:ea typeface="Arial" pitchFamily="34" charset="-122"/>
-                <a:cs typeface="Arial" pitchFamily="34" charset="-120"/>
-              </a:rPr>
-              <a:t>10 min</a:t>
-            </a:r>
-            <a:endParaRPr lang="en-US" sz="1100" dirty="0"/>
-          </a:p>
-        </p:txBody>
-      </p:sp>
-      <p:sp>
-        <p:nvSpPr>
-          <p:cNvPr id="23" name="Text 20"/>
-          <p:cNvSpPr/>
-          <p:nvPr/>
-        </p:nvSpPr>
-        <p:spPr>
-          <a:xfrm>
-            <a:off x="2011680" y="2871216"/>
-            <a:ext cx="4114800" cy="530352"/>
-          </a:xfrm>
-          <a:prstGeom prst="rect">
-            <a:avLst/>
-          </a:prstGeom>
-          <a:noFill/>
-          <a:ln/>
-        </p:spPr>
-        <p:txBody>
-          <a:bodyPr wrap="square" lIns="0" tIns="0" rIns="0" bIns="0" rtlCol="0" anchor="ctr"/>
-          <a:lstStyle/>
-          <a:p>
-            <a:pPr indent="0" marL="0">
-              <a:buNone/>
-            </a:pPr>
-            <a:r>
-              <a:rPr lang="en-US" sz="1200" dirty="0">
-                <a:solidFill>
-                  <a:srgbClr val="FFFFFF"/>
-                </a:solidFill>
-                <a:latin typeface="Arial" pitchFamily="34" charset="0"/>
-                <a:ea typeface="Arial" pitchFamily="34" charset="-122"/>
-                <a:cs typeface="Arial" pitchFamily="34" charset="-120"/>
-              </a:rPr>
-              <a:t>Run npm install &amp;&amp; npm start</a:t>
-            </a:r>
-            <a:endParaRPr lang="en-US" sz="1200" dirty="0"/>
-          </a:p>
-        </p:txBody>
-      </p:sp>
-      <p:sp>
-        <p:nvSpPr>
-          <p:cNvPr id="24" name="Text 21"/>
-          <p:cNvSpPr/>
-          <p:nvPr/>
-        </p:nvSpPr>
-        <p:spPr>
-          <a:xfrm>
-            <a:off x="6217920" y="2871216"/>
-            <a:ext cx="2194560" cy="530352"/>
-          </a:xfrm>
-          <a:prstGeom prst="rect">
-            <a:avLst/>
-          </a:prstGeom>
-          <a:noFill/>
-          <a:ln/>
-        </p:spPr>
-        <p:txBody>
-          <a:bodyPr wrap="square" lIns="0" tIns="0" rIns="0" bIns="0" rtlCol="0" anchor="ctr"/>
-          <a:lstStyle/>
-          <a:p>
-            <a:pPr indent="0" marL="0">
-              <a:buNone/>
-            </a:pPr>
-            <a:r>
-              <a:rPr lang="en-US" sz="1000" i="1" dirty="0">
-                <a:solidFill>
-                  <a:srgbClr val="A0A0A0"/>
-                </a:solidFill>
-                <a:latin typeface="Arial" pitchFamily="34" charset="0"/>
-                <a:ea typeface="Arial" pitchFamily="34" charset="-122"/>
-                <a:cs typeface="Arial" pitchFamily="34" charset="-120"/>
-              </a:rPr>
-              <a:t>Open http://localhost:3000</a:t>
-            </a:r>
-            <a:endParaRPr lang="en-US" sz="1000" dirty="0"/>
-          </a:p>
-        </p:txBody>
-      </p:sp>
-      <p:sp>
-        <p:nvSpPr>
-          <p:cNvPr id="25" name="Shape 22"/>
-          <p:cNvSpPr/>
-          <p:nvPr/>
-        </p:nvSpPr>
-        <p:spPr>
-          <a:xfrm>
-            <a:off x="548640" y="3493008"/>
-            <a:ext cx="8046720" cy="530352"/>
-          </a:xfrm>
-          <a:prstGeom prst="rect">
-            <a:avLst/>
-          </a:prstGeom>
-          <a:solidFill>
-            <a:srgbClr val="0A1A35"/>
-          </a:solidFill>
-          <a:ln/>
-        </p:spPr>
-      </p:sp>
-      <p:sp>
-        <p:nvSpPr>
-          <p:cNvPr id="26" name="Shape 23"/>
-          <p:cNvSpPr/>
-          <p:nvPr/>
-        </p:nvSpPr>
-        <p:spPr>
-          <a:xfrm>
-            <a:off x="548640" y="3493008"/>
-            <a:ext cx="64008" cy="530352"/>
-          </a:xfrm>
-          <a:prstGeom prst="rect">
-            <a:avLst/>
-          </a:prstGeom>
-          <a:solidFill>
-            <a:srgbClr val="C5A55A"/>
-          </a:solidFill>
-          <a:ln/>
-        </p:spPr>
-      </p:sp>
-      <p:sp>
-        <p:nvSpPr>
-          <p:cNvPr id="27" name="Text 24"/>
-          <p:cNvSpPr/>
-          <p:nvPr/>
-        </p:nvSpPr>
-        <p:spPr>
-          <a:xfrm>
-            <a:off x="822960" y="3493008"/>
-            <a:ext cx="1097280" cy="530352"/>
-          </a:xfrm>
-          <a:prstGeom prst="rect">
-            <a:avLst/>
-          </a:prstGeom>
-          <a:noFill/>
-          <a:ln/>
-        </p:spPr>
-        <p:txBody>
-          <a:bodyPr wrap="square" lIns="0" tIns="0" rIns="0" bIns="0" rtlCol="0" anchor="ctr"/>
-          <a:lstStyle/>
-          <a:p>
-            <a:pPr indent="0" marL="0">
-              <a:buNone/>
-            </a:pPr>
-            <a:r>
-              <a:rPr lang="en-US" sz="1100" b="1" dirty="0">
-                <a:solidFill>
-                  <a:srgbClr val="C5A55A"/>
-                </a:solidFill>
-                <a:latin typeface="Arial" pitchFamily="34" charset="0"/>
-                <a:ea typeface="Arial" pitchFamily="34" charset="-122"/>
-                <a:cs typeface="Arial" pitchFamily="34" charset="-120"/>
-              </a:rPr>
-              <a:t>15 min</a:t>
-            </a:r>
-            <a:endParaRPr lang="en-US" sz="1100" dirty="0"/>
-          </a:p>
-        </p:txBody>
-      </p:sp>
-      <p:sp>
-        <p:nvSpPr>
-          <p:cNvPr id="28" name="Text 25"/>
-          <p:cNvSpPr/>
-          <p:nvPr/>
-        </p:nvSpPr>
-        <p:spPr>
-          <a:xfrm>
-            <a:off x="2011680" y="3493008"/>
-            <a:ext cx="4114800" cy="530352"/>
-          </a:xfrm>
-          <a:prstGeom prst="rect">
-            <a:avLst/>
-          </a:prstGeom>
-          <a:noFill/>
-          <a:ln/>
-        </p:spPr>
-        <p:txBody>
-          <a:bodyPr wrap="square" lIns="0" tIns="0" rIns="0" bIns="0" rtlCol="0" anchor="ctr"/>
-          <a:lstStyle/>
-          <a:p>
-            <a:pPr indent="0" marL="0">
-              <a:buNone/>
-            </a:pPr>
-            <a:r>
-              <a:rPr lang="en-US" sz="1200" dirty="0">
-                <a:solidFill>
-                  <a:srgbClr val="FFFFFF"/>
-                </a:solidFill>
-                <a:latin typeface="Arial" pitchFamily="34" charset="0"/>
-                <a:ea typeface="Arial" pitchFamily="34" charset="-122"/>
-                <a:cs typeface="Arial" pitchFamily="34" charset="-120"/>
-              </a:rPr>
-              <a:t>Install Claude Code (optional but recommended)</a:t>
-            </a:r>
-            <a:endParaRPr lang="en-US" sz="1200" dirty="0"/>
-          </a:p>
-        </p:txBody>
-      </p:sp>
-      <p:sp>
-        <p:nvSpPr>
-          <p:cNvPr id="29" name="Text 26"/>
-          <p:cNvSpPr/>
-          <p:nvPr/>
-        </p:nvSpPr>
-        <p:spPr>
-          <a:xfrm>
-            <a:off x="6217920" y="3493008"/>
-            <a:ext cx="2194560" cy="530352"/>
-          </a:xfrm>
-          <a:prstGeom prst="rect">
-            <a:avLst/>
-          </a:prstGeom>
-          <a:noFill/>
-          <a:ln/>
-        </p:spPr>
-        <p:txBody>
-          <a:bodyPr wrap="square" lIns="0" tIns="0" rIns="0" bIns="0" rtlCol="0" anchor="ctr"/>
-          <a:lstStyle/>
-          <a:p>
-            <a:pPr indent="0" marL="0">
-              <a:buNone/>
-            </a:pPr>
-            <a:r>
-              <a:rPr lang="en-US" sz="1000" i="1" dirty="0">
-                <a:solidFill>
-                  <a:srgbClr val="A0A0A0"/>
-                </a:solidFill>
-                <a:latin typeface="Arial" pitchFamily="34" charset="0"/>
-                <a:ea typeface="Arial" pitchFamily="34" charset="-122"/>
-                <a:cs typeface="Arial" pitchFamily="34" charset="-120"/>
-              </a:rPr>
-              <a:t>claude.com/claude-code</a:t>
-            </a:r>
-            <a:endParaRPr lang="en-US" sz="1000" dirty="0"/>
-          </a:p>
-        </p:txBody>
-      </p:sp>
-      <p:sp>
-        <p:nvSpPr>
-          <p:cNvPr id="30" name="Shape 27"/>
-          <p:cNvSpPr/>
-          <p:nvPr/>
-        </p:nvSpPr>
-        <p:spPr>
-          <a:xfrm>
-            <a:off x="548640" y="4114800"/>
-            <a:ext cx="8046720" cy="530352"/>
-          </a:xfrm>
-          <a:prstGeom prst="rect">
-            <a:avLst/>
-          </a:prstGeom>
-          <a:solidFill>
-            <a:srgbClr val="0A1A35"/>
-          </a:solidFill>
-          <a:ln/>
-        </p:spPr>
-      </p:sp>
-      <p:sp>
-        <p:nvSpPr>
-          <p:cNvPr id="31" name="Shape 28"/>
-          <p:cNvSpPr/>
-          <p:nvPr/>
-        </p:nvSpPr>
-        <p:spPr>
-          <a:xfrm>
-            <a:off x="548640" y="4114800"/>
-            <a:ext cx="64008" cy="530352"/>
-          </a:xfrm>
-          <a:prstGeom prst="rect">
-            <a:avLst/>
-          </a:prstGeom>
-          <a:solidFill>
-            <a:srgbClr val="C5A55A"/>
-          </a:solidFill>
-          <a:ln/>
-        </p:spPr>
-      </p:sp>
-      <p:sp>
-        <p:nvSpPr>
-          <p:cNvPr id="32" name="Text 29"/>
-          <p:cNvSpPr/>
-          <p:nvPr/>
-        </p:nvSpPr>
-        <p:spPr>
-          <a:xfrm>
-            <a:off x="822960" y="4114800"/>
-            <a:ext cx="1097280" cy="530352"/>
-          </a:xfrm>
-          <a:prstGeom prst="rect">
-            <a:avLst/>
-          </a:prstGeom>
-          <a:noFill/>
-          <a:ln/>
-        </p:spPr>
-        <p:txBody>
-          <a:bodyPr wrap="square" lIns="0" tIns="0" rIns="0" bIns="0" rtlCol="0" anchor="ctr"/>
-          <a:lstStyle/>
-          <a:p>
-            <a:pPr indent="0" marL="0">
-              <a:buNone/>
-            </a:pPr>
-            <a:r>
-              <a:rPr lang="en-US" sz="1100" b="1" dirty="0">
-                <a:solidFill>
-                  <a:srgbClr val="C5A55A"/>
-                </a:solidFill>
-                <a:latin typeface="Arial" pitchFamily="34" charset="0"/>
-                <a:ea typeface="Arial" pitchFamily="34" charset="-122"/>
-                <a:cs typeface="Arial" pitchFamily="34" charset="-120"/>
-              </a:rPr>
-              <a:t>30 min</a:t>
-            </a:r>
-            <a:endParaRPr lang="en-US" sz="1100" dirty="0"/>
-          </a:p>
-        </p:txBody>
-      </p:sp>
-      <p:sp>
-        <p:nvSpPr>
-          <p:cNvPr id="33" name="Text 30"/>
-          <p:cNvSpPr/>
-          <p:nvPr/>
-        </p:nvSpPr>
-        <p:spPr>
-          <a:xfrm>
-            <a:off x="2011680" y="4114800"/>
-            <a:ext cx="4114800" cy="530352"/>
-          </a:xfrm>
-          <a:prstGeom prst="rect">
-            <a:avLst/>
-          </a:prstGeom>
-          <a:noFill/>
-          <a:ln/>
-        </p:spPr>
-        <p:txBody>
-          <a:bodyPr wrap="square" lIns="0" tIns="0" rIns="0" bIns="0" rtlCol="0" anchor="ctr"/>
-          <a:lstStyle/>
-          <a:p>
-            <a:pPr indent="0" marL="0">
-              <a:buNone/>
-            </a:pPr>
-            <a:r>
-              <a:rPr lang="en-US" sz="1200" dirty="0">
-                <a:solidFill>
-                  <a:srgbClr val="FFFFFF"/>
-                </a:solidFill>
-                <a:latin typeface="Arial" pitchFamily="34" charset="0"/>
-                <a:ea typeface="Arial" pitchFamily="34" charset="-122"/>
-                <a:cs typeface="Arial" pitchFamily="34" charset="-120"/>
-              </a:rPr>
-              <a:t>Make a small PR (fix a typo in README)</a:t>
-            </a:r>
-            <a:endParaRPr lang="en-US" sz="1200" dirty="0"/>
-          </a:p>
-        </p:txBody>
-      </p:sp>
-      <p:sp>
-        <p:nvSpPr>
-          <p:cNvPr id="34" name="Text 31"/>
-          <p:cNvSpPr/>
-          <p:nvPr/>
-        </p:nvSpPr>
-        <p:spPr>
-          <a:xfrm>
-            <a:off x="6217920" y="4114800"/>
-            <a:ext cx="2194560" cy="530352"/>
-          </a:xfrm>
-          <a:prstGeom prst="rect">
-            <a:avLst/>
-          </a:prstGeom>
-          <a:noFill/>
-          <a:ln/>
-        </p:spPr>
-        <p:txBody>
-          <a:bodyPr wrap="square" lIns="0" tIns="0" rIns="0" bIns="0" rtlCol="0" anchor="ctr"/>
-          <a:lstStyle/>
-          <a:p>
-            <a:pPr indent="0" marL="0">
-              <a:buNone/>
-            </a:pPr>
-            <a:r>
-              <a:rPr lang="en-US" sz="1000" i="1" dirty="0">
-                <a:solidFill>
-                  <a:srgbClr val="A0A0A0"/>
-                </a:solidFill>
-                <a:latin typeface="Arial" pitchFamily="34" charset="0"/>
-                <a:ea typeface="Arial" pitchFamily="34" charset="-122"/>
-                <a:cs typeface="Arial" pitchFamily="34" charset="-120"/>
-              </a:rPr>
-              <a:t>Practice the workflow</a:t>
-            </a:r>
-            <a:endParaRPr lang="en-US" sz="1000" dirty="0"/>
+                <a:latin typeface="monospace" pitchFamily="34" charset="0"/>
+                <a:ea typeface="monospace" pitchFamily="34" charset="-122"/>
+                <a:cs typeface="monospace" pitchFamily="34" charset="-120"/>
+              </a:rPr>
+              <a:t>File: pitch/Del-Norte-GitHub-Flow.pptx · docs/GITHUB-PROCESS.md</a:t>
+            </a:r>
+            <a:endParaRPr lang="en-US" sz="900" dirty="0"/>
           </a:p>
         </p:txBody>
       </p:sp>
@@ -4528,7 +4093,7 @@
                 <a:ea typeface="Arial Black" pitchFamily="34" charset="-122"/>
                 <a:cs typeface="Arial Black" pitchFamily="34" charset="-120"/>
               </a:rPr>
-              <a:t>COMMON TASKS</a:t>
+              <a:t>COMMON COMMANDS</a:t>
             </a:r>
             <a:endParaRPr lang="en-US" sz="2400" dirty="0"/>
           </a:p>
@@ -5642,7 +5207,7 @@
                 <a:ea typeface="Arial" pitchFamily="34" charset="-122"/>
                 <a:cs typeface="Arial" pitchFamily="34" charset="-120"/>
               </a:rPr>
-              <a:t>Test plan</a:t>
+              <a:t>Dev environment setup</a:t>
             </a:r>
             <a:endParaRPr lang="en-US" sz="1200" dirty="0"/>
           </a:p>
@@ -5681,7 +5246,7 @@
                 <a:ea typeface="monospace" pitchFamily="34" charset="-122"/>
                 <a:cs typeface="monospace" pitchFamily="34" charset="-120"/>
               </a:rPr>
-              <a:t>docs/TESTING.md</a:t>
+              <a:t>docs/DEV-ENVIRONMENT-SETUP.md</a:t>
             </a:r>
             <a:endParaRPr lang="en-US" sz="1100" dirty="0"/>
           </a:p>
@@ -5760,7 +5325,7 @@
                 <a:ea typeface="Arial" pitchFamily="34" charset="-122"/>
                 <a:cs typeface="Arial" pitchFamily="34" charset="-120"/>
               </a:rPr>
-              <a:t>Security model</a:t>
+              <a:t>GitHub process</a:t>
             </a:r>
             <a:endParaRPr lang="en-US" sz="1200" dirty="0"/>
           </a:p>
@@ -5799,7 +5364,7 @@
                 <a:ea typeface="monospace" pitchFamily="34" charset="-122"/>
                 <a:cs typeface="monospace" pitchFamily="34" charset="-120"/>
               </a:rPr>
-              <a:t>docs/SECURITY.md</a:t>
+              <a:t>docs/GITHUB-PROCESS.md</a:t>
             </a:r>
             <a:endParaRPr lang="en-US" sz="1100" dirty="0"/>
           </a:p>
@@ -5878,7 +5443,7 @@
                 <a:ea typeface="Arial" pitchFamily="34" charset="-122"/>
                 <a:cs typeface="Arial" pitchFamily="34" charset="-120"/>
               </a:rPr>
-              <a:t>POS integrations</a:t>
+              <a:t>Test plan</a:t>
             </a:r>
             <a:endParaRPr lang="en-US" sz="1200" dirty="0"/>
           </a:p>
@@ -5917,7 +5482,7 @@
                 <a:ea typeface="monospace" pitchFamily="34" charset="-122"/>
                 <a:cs typeface="monospace" pitchFamily="34" charset="-120"/>
               </a:rPr>
-              <a:t>docs/POS-COMPATIBILITY.md</a:t>
+              <a:t>docs/TESTING.md</a:t>
             </a:r>
             <a:endParaRPr lang="en-US" sz="1100" dirty="0"/>
           </a:p>
@@ -5996,7 +5561,7 @@
                 <a:ea typeface="Arial" pitchFamily="34" charset="-122"/>
                 <a:cs typeface="Arial" pitchFamily="34" charset="-120"/>
               </a:rPr>
-              <a:t>Live server</a:t>
+              <a:t>Security model</a:t>
             </a:r>
             <a:endParaRPr lang="en-US" sz="1200" dirty="0"/>
           </a:p>
@@ -6035,7 +5600,7 @@
                 <a:ea typeface="monospace" pitchFamily="34" charset="-122"/>
                 <a:cs typeface="monospace" pitchFamily="34" charset="-120"/>
               </a:rPr>
-              <a:t>https://web-production-9f35d.up.railway.app</a:t>
+              <a:t>docs/SECURITY.md</a:t>
             </a:r>
             <a:endParaRPr lang="en-US" sz="1100" dirty="0"/>
           </a:p>
@@ -6114,7 +5679,7 @@
                 <a:ea typeface="Arial" pitchFamily="34" charset="-122"/>
                 <a:cs typeface="Arial" pitchFamily="34" charset="-120"/>
               </a:rPr>
-              <a:t>Admin dashboard</a:t>
+              <a:t>POS integrations</a:t>
             </a:r>
             <a:endParaRPr lang="en-US" sz="1200" dirty="0"/>
           </a:p>
@@ -6153,7 +5718,7 @@
                 <a:ea typeface="monospace" pitchFamily="34" charset="-122"/>
                 <a:cs typeface="monospace" pitchFamily="34" charset="-120"/>
               </a:rPr>
-              <a:t>/admin</a:t>
+              <a:t>docs/POS-COMPATIBILITY.md</a:t>
             </a:r>
             <a:endParaRPr lang="en-US" sz="1100" dirty="0"/>
           </a:p>
@@ -6232,7 +5797,7 @@
                 <a:ea typeface="Arial" pitchFamily="34" charset="-122"/>
                 <a:cs typeface="Arial" pitchFamily="34" charset="-120"/>
               </a:rPr>
-              <a:t>Apple Developer portal</a:t>
+              <a:t>Live server</a:t>
             </a:r>
             <a:endParaRPr lang="en-US" sz="1200" dirty="0"/>
           </a:p>
@@ -6271,7 +5836,7 @@
                 <a:ea typeface="monospace" pitchFamily="34" charset="-122"/>
                 <a:cs typeface="monospace" pitchFamily="34" charset="-120"/>
               </a:rPr>
-              <a:t>https://developer.apple.com</a:t>
+              <a:t>https://web-production-9f35d.up.railway.app</a:t>
             </a:r>
             <a:endParaRPr lang="en-US" sz="1100" dirty="0"/>
           </a:p>
@@ -6456,23 +6021,23 @@
         <p:spPr>
           <a:xfrm>
             <a:off x="1280160" y="1005840"/>
-            <a:ext cx="1828800" cy="502920"/>
-          </a:xfrm>
-          <a:prstGeom prst="rect">
-            <a:avLst/>
-          </a:prstGeom>
-          <a:noFill/>
-          <a:ln/>
-        </p:spPr>
-        <p:txBody>
-          <a:bodyPr wrap="square" lIns="0" tIns="0" rIns="0" bIns="0" rtlCol="0" anchor="ctr"/>
-          <a:lstStyle/>
-          <a:p>
-            <a:pPr indent="0" marL="0">
-              <a:buNone/>
-            </a:pPr>
-            <a:r>
-              <a:rPr lang="en-US" sz="1300" b="1" dirty="0">
+            <a:ext cx="2011680" cy="502920"/>
+          </a:xfrm>
+          <a:prstGeom prst="rect">
+            <a:avLst/>
+          </a:prstGeom>
+          <a:noFill/>
+          <a:ln/>
+        </p:spPr>
+        <p:txBody>
+          <a:bodyPr wrap="square" lIns="0" tIns="0" rIns="0" bIns="0" rtlCol="0" anchor="ctr"/>
+          <a:lstStyle/>
+          <a:p>
+            <a:pPr indent="0" marL="0">
+              <a:buNone/>
+            </a:pPr>
+            <a:r>
+              <a:rPr lang="en-US" sz="1200" b="1" dirty="0">
                 <a:solidFill>
                   <a:srgbClr val="C5A55A"/>
                 </a:solidFill>
@@ -6480,9 +6045,9 @@
                 <a:ea typeface="Arial" pitchFamily="34" charset="-122"/>
                 <a:cs typeface="Arial" pitchFamily="34" charset="-120"/>
               </a:rPr>
-              <a:t>Day 1</a:t>
-            </a:r>
-            <a:endParaRPr lang="en-US" sz="1300" dirty="0"/>
+              <a:t>Day 1 AM</a:t>
+            </a:r>
+            <a:endParaRPr lang="en-US" sz="1200" dirty="0"/>
           </a:p>
         </p:txBody>
       </p:sp>
@@ -6494,7 +6059,7 @@
         </p:nvSpPr>
         <p:spPr>
           <a:xfrm>
-            <a:off x="3200400" y="1005840"/>
+            <a:off x="3291840" y="1005840"/>
             <a:ext cx="5212080" cy="502920"/>
           </a:xfrm>
           <a:prstGeom prst="rect">
@@ -6511,7 +6076,7 @@
               <a:buNone/>
             </a:pPr>
             <a:r>
-              <a:rPr lang="en-US" sz="1200" dirty="0">
+              <a:rPr lang="en-US" sz="1100" dirty="0">
                 <a:solidFill>
                   <a:srgbClr val="FFFFFF"/>
                 </a:solidFill>
@@ -6519,9 +6084,9 @@
                 <a:ea typeface="Arial" pitchFamily="34" charset="-122"/>
                 <a:cs typeface="Arial" pitchFamily="34" charset="-120"/>
               </a:rPr>
-              <a:t>Environment set up, first PR merged</a:t>
-            </a:r>
-            <a:endParaRPr lang="en-US" sz="1200" dirty="0"/>
+              <a:t>Read this deck + Dev Environment Setup deck. Install everything.</a:t>
+            </a:r>
+            <a:endParaRPr lang="en-US" sz="1100" dirty="0"/>
           </a:p>
         </p:txBody>
       </p:sp>
@@ -6613,23 +6178,23 @@
         <p:spPr>
           <a:xfrm>
             <a:off x="1280160" y="1600200"/>
-            <a:ext cx="1828800" cy="502920"/>
-          </a:xfrm>
-          <a:prstGeom prst="rect">
-            <a:avLst/>
-          </a:prstGeom>
-          <a:noFill/>
-          <a:ln/>
-        </p:spPr>
-        <p:txBody>
-          <a:bodyPr wrap="square" lIns="0" tIns="0" rIns="0" bIns="0" rtlCol="0" anchor="ctr"/>
-          <a:lstStyle/>
-          <a:p>
-            <a:pPr indent="0" marL="0">
-              <a:buNone/>
-            </a:pPr>
-            <a:r>
-              <a:rPr lang="en-US" sz="1300" b="1" dirty="0">
+            <a:ext cx="2011680" cy="502920"/>
+          </a:xfrm>
+          <a:prstGeom prst="rect">
+            <a:avLst/>
+          </a:prstGeom>
+          <a:noFill/>
+          <a:ln/>
+        </p:spPr>
+        <p:txBody>
+          <a:bodyPr wrap="square" lIns="0" tIns="0" rIns="0" bIns="0" rtlCol="0" anchor="ctr"/>
+          <a:lstStyle/>
+          <a:p>
+            <a:pPr indent="0" marL="0">
+              <a:buNone/>
+            </a:pPr>
+            <a:r>
+              <a:rPr lang="en-US" sz="1200" b="1" dirty="0">
                 <a:solidFill>
                   <a:srgbClr val="C5A55A"/>
                 </a:solidFill>
@@ -6637,9 +6202,9 @@
                 <a:ea typeface="Arial" pitchFamily="34" charset="-122"/>
                 <a:cs typeface="Arial" pitchFamily="34" charset="-120"/>
               </a:rPr>
-              <a:t>Day 2</a:t>
-            </a:r>
-            <a:endParaRPr lang="en-US" sz="1300" dirty="0"/>
+              <a:t>Day 1 PM</a:t>
+            </a:r>
+            <a:endParaRPr lang="en-US" sz="1200" dirty="0"/>
           </a:p>
         </p:txBody>
       </p:sp>
@@ -6651,7 +6216,7 @@
         </p:nvSpPr>
         <p:spPr>
           <a:xfrm>
-            <a:off x="3200400" y="1600200"/>
+            <a:off x="3291840" y="1600200"/>
             <a:ext cx="5212080" cy="502920"/>
           </a:xfrm>
           <a:prstGeom prst="rect">
@@ -6668,7 +6233,7 @@
               <a:buNone/>
             </a:pPr>
             <a:r>
-              <a:rPr lang="en-US" sz="1200" dirty="0">
+              <a:rPr lang="en-US" sz="1100" dirty="0">
                 <a:solidFill>
                   <a:srgbClr val="FFFFFF"/>
                 </a:solidFill>
@@ -6676,9 +6241,9 @@
                 <a:ea typeface="Arial" pitchFamily="34" charset="-122"/>
                 <a:cs typeface="Arial" pitchFamily="34" charset="-120"/>
               </a:rPr>
-              <a:t>Read the code, understand pass generation flow</a:t>
-            </a:r>
-            <a:endParaRPr lang="en-US" sz="1200" dirty="0"/>
+              <a:t>Read GitHub Process deck. Make a small PR (typo fix). Get it merged.</a:t>
+            </a:r>
+            <a:endParaRPr lang="en-US" sz="1100" dirty="0"/>
           </a:p>
         </p:txBody>
       </p:sp>
@@ -6770,23 +6335,23 @@
         <p:spPr>
           <a:xfrm>
             <a:off x="1280160" y="2194560"/>
-            <a:ext cx="1828800" cy="502920"/>
-          </a:xfrm>
-          <a:prstGeom prst="rect">
-            <a:avLst/>
-          </a:prstGeom>
-          <a:noFill/>
-          <a:ln/>
-        </p:spPr>
-        <p:txBody>
-          <a:bodyPr wrap="square" lIns="0" tIns="0" rIns="0" bIns="0" rtlCol="0" anchor="ctr"/>
-          <a:lstStyle/>
-          <a:p>
-            <a:pPr indent="0" marL="0">
-              <a:buNone/>
-            </a:pPr>
-            <a:r>
-              <a:rPr lang="en-US" sz="1300" b="1" dirty="0">
+            <a:ext cx="2011680" cy="502920"/>
+          </a:xfrm>
+          <a:prstGeom prst="rect">
+            <a:avLst/>
+          </a:prstGeom>
+          <a:noFill/>
+          <a:ln/>
+        </p:spPr>
+        <p:txBody>
+          <a:bodyPr wrap="square" lIns="0" tIns="0" rIns="0" bIns="0" rtlCol="0" anchor="ctr"/>
+          <a:lstStyle/>
+          <a:p>
+            <a:pPr indent="0" marL="0">
+              <a:buNone/>
+            </a:pPr>
+            <a:r>
+              <a:rPr lang="en-US" sz="1200" b="1" dirty="0">
                 <a:solidFill>
                   <a:srgbClr val="C5A55A"/>
                 </a:solidFill>
@@ -6794,9 +6359,9 @@
                 <a:ea typeface="Arial" pitchFamily="34" charset="-122"/>
                 <a:cs typeface="Arial" pitchFamily="34" charset="-120"/>
               </a:rPr>
-              <a:t>Day 3</a:t>
-            </a:r>
-            <a:endParaRPr lang="en-US" sz="1300" dirty="0"/>
+              <a:t>Day 2-3</a:t>
+            </a:r>
+            <a:endParaRPr lang="en-US" sz="1200" dirty="0"/>
           </a:p>
         </p:txBody>
       </p:sp>
@@ -6808,7 +6373,7 @@
         </p:nvSpPr>
         <p:spPr>
           <a:xfrm>
-            <a:off x="3200400" y="2194560"/>
+            <a:off x="3291840" y="2194560"/>
             <a:ext cx="5212080" cy="502920"/>
           </a:xfrm>
           <a:prstGeom prst="rect">
@@ -6825,7 +6390,7 @@
               <a:buNone/>
             </a:pPr>
             <a:r>
-              <a:rPr lang="en-US" sz="1200" dirty="0">
+              <a:rPr lang="en-US" sz="1100" dirty="0">
                 <a:solidFill>
                   <a:srgbClr val="FFFFFF"/>
                 </a:solidFill>
@@ -6833,9 +6398,9 @@
                 <a:ea typeface="Arial" pitchFamily="34" charset="-122"/>
                 <a:cs typeface="Arial" pitchFamily="34" charset="-120"/>
               </a:rPr>
-              <a:t>Pick a Priority 1 task from docs/TASKS.md</a:t>
-            </a:r>
-            <a:endParaRPr lang="en-US" sz="1200" dirty="0"/>
+              <a:t>Read the code. Understand how pass generation works.</a:t>
+            </a:r>
+            <a:endParaRPr lang="en-US" sz="1100" dirty="0"/>
           </a:p>
         </p:txBody>
       </p:sp>
@@ -6927,23 +6492,23 @@
         <p:spPr>
           <a:xfrm>
             <a:off x="1280160" y="2788920"/>
-            <a:ext cx="1828800" cy="502920"/>
-          </a:xfrm>
-          <a:prstGeom prst="rect">
-            <a:avLst/>
-          </a:prstGeom>
-          <a:noFill/>
-          <a:ln/>
-        </p:spPr>
-        <p:txBody>
-          <a:bodyPr wrap="square" lIns="0" tIns="0" rIns="0" bIns="0" rtlCol="0" anchor="ctr"/>
-          <a:lstStyle/>
-          <a:p>
-            <a:pPr indent="0" marL="0">
-              <a:buNone/>
-            </a:pPr>
-            <a:r>
-              <a:rPr lang="en-US" sz="1300" b="1" dirty="0">
+            <a:ext cx="2011680" cy="502920"/>
+          </a:xfrm>
+          <a:prstGeom prst="rect">
+            <a:avLst/>
+          </a:prstGeom>
+          <a:noFill/>
+          <a:ln/>
+        </p:spPr>
+        <p:txBody>
+          <a:bodyPr wrap="square" lIns="0" tIns="0" rIns="0" bIns="0" rtlCol="0" anchor="ctr"/>
+          <a:lstStyle/>
+          <a:p>
+            <a:pPr indent="0" marL="0">
+              <a:buNone/>
+            </a:pPr>
+            <a:r>
+              <a:rPr lang="en-US" sz="1200" b="1" dirty="0">
                 <a:solidFill>
                   <a:srgbClr val="C5A55A"/>
                 </a:solidFill>
@@ -6951,9 +6516,9 @@
                 <a:ea typeface="Arial" pitchFamily="34" charset="-122"/>
                 <a:cs typeface="Arial" pitchFamily="34" charset="-120"/>
               </a:rPr>
-              <a:t>Day 4</a:t>
-            </a:r>
-            <a:endParaRPr lang="en-US" sz="1300" dirty="0"/>
+              <a:t>Day 3-4</a:t>
+            </a:r>
+            <a:endParaRPr lang="en-US" sz="1200" dirty="0"/>
           </a:p>
         </p:txBody>
       </p:sp>
@@ -6965,7 +6530,7 @@
         </p:nvSpPr>
         <p:spPr>
           <a:xfrm>
-            <a:off x="3200400" y="2788920"/>
+            <a:off x="3291840" y="2788920"/>
             <a:ext cx="5212080" cy="502920"/>
           </a:xfrm>
           <a:prstGeom prst="rect">
@@ -6982,7 +6547,7 @@
               <a:buNone/>
             </a:pPr>
             <a:r>
-              <a:rPr lang="en-US" sz="1200" dirty="0">
+              <a:rPr lang="en-US" sz="1100" dirty="0">
                 <a:solidFill>
                   <a:srgbClr val="FFFFFF"/>
                 </a:solidFill>
@@ -6990,9 +6555,9 @@
                 <a:ea typeface="Arial" pitchFamily="34" charset="-122"/>
                 <a:cs typeface="Arial" pitchFamily="34" charset="-120"/>
               </a:rPr>
-              <a:t>Open a draft PR with progress, get early feedback</a:t>
-            </a:r>
-            <a:endParaRPr lang="en-US" sz="1200" dirty="0"/>
+              <a:t>Pick a Priority 1 task from docs/TASKS.md</a:t>
+            </a:r>
+            <a:endParaRPr lang="en-US" sz="1100" dirty="0"/>
           </a:p>
         </p:txBody>
       </p:sp>
@@ -7084,23 +6649,23 @@
         <p:spPr>
           <a:xfrm>
             <a:off x="1280160" y="3383280"/>
-            <a:ext cx="1828800" cy="502920"/>
-          </a:xfrm>
-          <a:prstGeom prst="rect">
-            <a:avLst/>
-          </a:prstGeom>
-          <a:noFill/>
-          <a:ln/>
-        </p:spPr>
-        <p:txBody>
-          <a:bodyPr wrap="square" lIns="0" tIns="0" rIns="0" bIns="0" rtlCol="0" anchor="ctr"/>
-          <a:lstStyle/>
-          <a:p>
-            <a:pPr indent="0" marL="0">
-              <a:buNone/>
-            </a:pPr>
-            <a:r>
-              <a:rPr lang="en-US" sz="1300" b="1" dirty="0">
+            <a:ext cx="2011680" cy="502920"/>
+          </a:xfrm>
+          <a:prstGeom prst="rect">
+            <a:avLst/>
+          </a:prstGeom>
+          <a:noFill/>
+          <a:ln/>
+        </p:spPr>
+        <p:txBody>
+          <a:bodyPr wrap="square" lIns="0" tIns="0" rIns="0" bIns="0" rtlCol="0" anchor="ctr"/>
+          <a:lstStyle/>
+          <a:p>
+            <a:pPr indent="0" marL="0">
+              <a:buNone/>
+            </a:pPr>
+            <a:r>
+              <a:rPr lang="en-US" sz="1200" b="1" dirty="0">
                 <a:solidFill>
                   <a:srgbClr val="C5A55A"/>
                 </a:solidFill>
@@ -7108,9 +6673,9 @@
                 <a:ea typeface="Arial" pitchFamily="34" charset="-122"/>
                 <a:cs typeface="Arial" pitchFamily="34" charset="-120"/>
               </a:rPr>
-              <a:t>Day 5</a:t>
-            </a:r>
-            <a:endParaRPr lang="en-US" sz="1300" dirty="0"/>
+              <a:t>Day 4-5</a:t>
+            </a:r>
+            <a:endParaRPr lang="en-US" sz="1200" dirty="0"/>
           </a:p>
         </p:txBody>
       </p:sp>
@@ -7122,7 +6687,7 @@
         </p:nvSpPr>
         <p:spPr>
           <a:xfrm>
-            <a:off x="3200400" y="3383280"/>
+            <a:off x="3291840" y="3383280"/>
             <a:ext cx="5212080" cy="502920"/>
           </a:xfrm>
           <a:prstGeom prst="rect">
@@ -7139,7 +6704,7 @@
               <a:buNone/>
             </a:pPr>
             <a:r>
-              <a:rPr lang="en-US" sz="1200" dirty="0">
+              <a:rPr lang="en-US" sz="1100" dirty="0">
                 <a:solidFill>
                   <a:srgbClr val="FFFFFF"/>
                 </a:solidFill>
@@ -7147,9 +6712,9 @@
                 <a:ea typeface="Arial" pitchFamily="34" charset="-122"/>
                 <a:cs typeface="Arial" pitchFamily="34" charset="-120"/>
               </a:rPr>
-              <a:t>Merge your first real feature</a:t>
-            </a:r>
-            <a:endParaRPr lang="en-US" sz="1200" dirty="0"/>
+              <a:t>Open a draft PR, get feedback, iterate, merge</a:t>
+            </a:r>
+            <a:endParaRPr lang="en-US" sz="1100" dirty="0"/>
           </a:p>
         </p:txBody>
       </p:sp>
@@ -7241,23 +6806,23 @@
         <p:spPr>
           <a:xfrm>
             <a:off x="1280160" y="3977640"/>
-            <a:ext cx="1828800" cy="502920"/>
-          </a:xfrm>
-          <a:prstGeom prst="rect">
-            <a:avLst/>
-          </a:prstGeom>
-          <a:noFill/>
-          <a:ln/>
-        </p:spPr>
-        <p:txBody>
-          <a:bodyPr wrap="square" lIns="0" tIns="0" rIns="0" bIns="0" rtlCol="0" anchor="ctr"/>
-          <a:lstStyle/>
-          <a:p>
-            <a:pPr indent="0" marL="0">
-              <a:buNone/>
-            </a:pPr>
-            <a:r>
-              <a:rPr lang="en-US" sz="1300" b="1" dirty="0">
+            <a:ext cx="2011680" cy="502920"/>
+          </a:xfrm>
+          <a:prstGeom prst="rect">
+            <a:avLst/>
+          </a:prstGeom>
+          <a:noFill/>
+          <a:ln/>
+        </p:spPr>
+        <p:txBody>
+          <a:bodyPr wrap="square" lIns="0" tIns="0" rIns="0" bIns="0" rtlCol="0" anchor="ctr"/>
+          <a:lstStyle/>
+          <a:p>
+            <a:pPr indent="0" marL="0">
+              <a:buNone/>
+            </a:pPr>
+            <a:r>
+              <a:rPr lang="en-US" sz="1200" b="1" dirty="0">
                 <a:solidFill>
                   <a:srgbClr val="C5A55A"/>
                 </a:solidFill>
@@ -7267,7 +6832,7 @@
               </a:rPr>
               <a:t>Week retro</a:t>
             </a:r>
-            <a:endParaRPr lang="en-US" sz="1300" dirty="0"/>
+            <a:endParaRPr lang="en-US" sz="1200" dirty="0"/>
           </a:p>
         </p:txBody>
       </p:sp>
@@ -7279,7 +6844,7 @@
         </p:nvSpPr>
         <p:spPr>
           <a:xfrm>
-            <a:off x="3200400" y="3977640"/>
+            <a:off x="3291840" y="3977640"/>
             <a:ext cx="5212080" cy="502920"/>
           </a:xfrm>
           <a:prstGeom prst="rect">
@@ -7296,7 +6861,7 @@
               <a:buNone/>
             </a:pPr>
             <a:r>
-              <a:rPr lang="en-US" sz="1200" dirty="0">
+              <a:rPr lang="en-US" sz="1100" dirty="0">
                 <a:solidFill>
                   <a:srgbClr val="FFFFFF"/>
                 </a:solidFill>
@@ -7306,7 +6871,7 @@
               </a:rPr>
               <a:t>What you learned, what was confusing, what's next</a:t>
             </a:r>
-            <a:endParaRPr lang="en-US" sz="1200" dirty="0"/>
+            <a:endParaRPr lang="en-US" sz="1100" dirty="0"/>
           </a:p>
         </p:txBody>
       </p:sp>
@@ -8145,7 +7710,7 @@
                 <a:ea typeface="Arial" pitchFamily="34" charset="-122"/>
                 <a:cs typeface="Arial" pitchFamily="34" charset="-120"/>
               </a:rPr>
-              <a:t>Don't chase perfect. Done and reviewable beats perfect and private.</a:t>
+              <a:t>Done and reviewable beats perfect and private.</a:t>
             </a:r>
             <a:endParaRPr lang="en-US" sz="1100" dirty="0"/>
           </a:p>
@@ -8369,13 +7934,13 @@
             <a:r>
               <a:rPr lang="en-US" sz="1100" dirty="0">
                 <a:solidFill>
-                  <a:srgbClr val="A0A0A0"/>
+                  <a:srgbClr val="D4B96A"/>
                 </a:solidFill>
                 <a:latin typeface="Arial" pitchFamily="34" charset="0"/>
                 <a:ea typeface="Arial" pitchFamily="34" charset="-122"/>
                 <a:cs typeface="Arial" pitchFamily="34" charset="-120"/>
               </a:rPr>
-              <a:t>Questions? Open a GitHub Issue or message your manager.</a:t>
+              <a:t>Next steps: Dev Environment Setup → GitHub Process → pick a task</a:t>
             </a:r>
             <a:endParaRPr lang="en-US" sz="1100" dirty="0"/>
           </a:p>

</xml_diff>